<commit_message>
Split ITEM tag rectangles and text into independent shapes in slide 1
Co-Authored-By: Claude Sonnet 5 <noreply@anthropic.com>
Claude-Session: https://claude.ai/code/session_01E9QvuhBZminJvrtKVH8YY8
</commit_message>
<xml_diff>
--- a/svetlana/outputs/2026-08-27-slide_6e-edited.pptx
+++ b/svetlana/outputs/2026-08-27-slide_6e-edited.pptx
@@ -3383,7 +3383,7 @@
       </p:pic>
       <p:sp>
         <p:nvSpPr>
-          <p:cNvPr id="101" name="Item Badge 101"/>
+          <p:cNvPr id="101" name="Item Badge 101 Rectangle"/>
           <p:cNvSpPr/>
           <p:nvPr/>
         </p:nvSpPr>
@@ -3409,6 +3409,26 @@
             </a:outerShdw>
           </a:effectLst>
         </p:spPr>
+      </p:sp>
+      <p:sp>
+        <p:nvSpPr>
+          <p:cNvPr id="111" name="Item Badge 101 Text"/>
+          <p:cNvSpPr txBox="1"/>
+          <p:nvPr/>
+        </p:nvSpPr>
+        <p:spPr>
+          <a:xfrm rot="-180000">
+            <a:off x="1444016" y="1433445"/>
+            <a:ext cx="1150000" cy="430000"/>
+          </a:xfrm>
+          <a:prstGeom prst="rect">
+            <a:avLst/>
+          </a:prstGeom>
+          <a:noFill/>
+          <a:ln>
+            <a:noFill/>
+          </a:ln>
+        </p:spPr>
         <p:txBody>
           <a:bodyPr wrap="square" lIns="91440" tIns="9144" rIns="45720" bIns="9144" rtlCol="0" anchor="ctr">
             <a:noAutofit/>
@@ -3530,7 +3550,7 @@
       </p:pic>
       <p:sp>
         <p:nvSpPr>
-          <p:cNvPr id="102" name="Item Badge 102"/>
+          <p:cNvPr id="102" name="Item Badge 102 Rectangle"/>
           <p:cNvSpPr/>
           <p:nvPr/>
         </p:nvSpPr>
@@ -3556,6 +3576,26 @@
             </a:outerShdw>
           </a:effectLst>
         </p:spPr>
+      </p:sp>
+      <p:sp>
+        <p:nvSpPr>
+          <p:cNvPr id="112" name="Item Badge 102 Text"/>
+          <p:cNvSpPr txBox="1"/>
+          <p:nvPr/>
+        </p:nvSpPr>
+        <p:spPr>
+          <a:xfrm rot="-180000">
+            <a:off x="3900658" y="1433445"/>
+            <a:ext cx="1150000" cy="430000"/>
+          </a:xfrm>
+          <a:prstGeom prst="rect">
+            <a:avLst/>
+          </a:prstGeom>
+          <a:noFill/>
+          <a:ln>
+            <a:noFill/>
+          </a:ln>
+        </p:spPr>
         <p:txBody>
           <a:bodyPr wrap="square" lIns="91440" tIns="9144" rIns="45720" bIns="9144" rtlCol="0" anchor="ctr">
             <a:noAutofit/>
@@ -3676,7 +3716,7 @@
       </p:pic>
       <p:sp>
         <p:nvSpPr>
-          <p:cNvPr id="103" name="Item Badge 103"/>
+          <p:cNvPr id="103" name="Item Badge 103 Rectangle"/>
           <p:cNvSpPr/>
           <p:nvPr/>
         </p:nvSpPr>
@@ -3702,6 +3742,26 @@
             </a:outerShdw>
           </a:effectLst>
         </p:spPr>
+      </p:sp>
+      <p:sp>
+        <p:nvSpPr>
+          <p:cNvPr id="113" name="Item Badge 103 Text"/>
+          <p:cNvSpPr txBox="1"/>
+          <p:nvPr/>
+        </p:nvSpPr>
+        <p:spPr>
+          <a:xfrm rot="-180000">
+            <a:off x="6341652" y="1433445"/>
+            <a:ext cx="1150000" cy="430000"/>
+          </a:xfrm>
+          <a:prstGeom prst="rect">
+            <a:avLst/>
+          </a:prstGeom>
+          <a:noFill/>
+          <a:ln>
+            <a:noFill/>
+          </a:ln>
+        </p:spPr>
         <p:txBody>
           <a:bodyPr wrap="square" lIns="91440" tIns="9144" rIns="45720" bIns="9144" rtlCol="0" anchor="ctr">
             <a:noAutofit/>
@@ -3822,7 +3882,7 @@
       </p:pic>
       <p:sp>
         <p:nvSpPr>
-          <p:cNvPr id="104" name="Item Badge 104"/>
+          <p:cNvPr id="104" name="Item Badge 104 Rectangle"/>
           <p:cNvSpPr/>
           <p:nvPr/>
         </p:nvSpPr>
@@ -3848,6 +3908,26 @@
             </a:outerShdw>
           </a:effectLst>
         </p:spPr>
+      </p:sp>
+      <p:sp>
+        <p:nvSpPr>
+          <p:cNvPr id="114" name="Item Badge 104 Text"/>
+          <p:cNvSpPr txBox="1"/>
+          <p:nvPr/>
+        </p:nvSpPr>
+        <p:spPr>
+          <a:xfrm rot="-180000">
+            <a:off x="1444016" y="4140445"/>
+            <a:ext cx="1150000" cy="430000"/>
+          </a:xfrm>
+          <a:prstGeom prst="rect">
+            <a:avLst/>
+          </a:prstGeom>
+          <a:noFill/>
+          <a:ln>
+            <a:noFill/>
+          </a:ln>
+        </p:spPr>
         <p:txBody>
           <a:bodyPr wrap="square" lIns="91440" tIns="9144" rIns="45720" bIns="9144" rtlCol="0" anchor="ctr">
             <a:noAutofit/>
@@ -3969,7 +4049,7 @@
       </p:pic>
       <p:sp>
         <p:nvSpPr>
-          <p:cNvPr id="105" name="Item Badge 105"/>
+          <p:cNvPr id="105" name="Item Badge 105 Rectangle"/>
           <p:cNvSpPr/>
           <p:nvPr/>
         </p:nvSpPr>
@@ -3994,6 +4074,26 @@
               </a:srgbClr>
             </a:outerShdw>
           </a:effectLst>
+        </p:spPr>
+      </p:sp>
+      <p:sp>
+        <p:nvSpPr>
+          <p:cNvPr id="115" name="Item Badge 105 Text"/>
+          <p:cNvSpPr txBox="1"/>
+          <p:nvPr/>
+        </p:nvSpPr>
+        <p:spPr>
+          <a:xfrm rot="-180000">
+            <a:off x="3900658" y="4140445"/>
+            <a:ext cx="1150000" cy="430000"/>
+          </a:xfrm>
+          <a:prstGeom prst="rect">
+            <a:avLst/>
+          </a:prstGeom>
+          <a:noFill/>
+          <a:ln>
+            <a:noFill/>
+          </a:ln>
         </p:spPr>
         <p:txBody>
           <a:bodyPr wrap="square" lIns="91440" tIns="9144" rIns="45720" bIns="9144" rtlCol="0" anchor="ctr">

</xml_diff>